<commit_message>
docs: refresh private editable deck with privacy resources
</commit_message>
<xml_diff>
--- a/backend/private/documentacao/apresentacao.pptx
+++ b/backend/private/documentacao/apresentacao.pptx
@@ -1857,7 +1857,7 @@
           <a:lstStyle/>
           <a:p>
             <a:r>
-              <a:t>Uma plataforma compartilhada, com operação segregada. Cadastros, viagens, reservas e históricos pertencem à empresa. Acesso definido pelo identificador da empresa e pelo perfil do usuário. Um profissional de várias empresas possui um cadastro em cada uma. Nexus administra empresas, planos e configurações da plataforma. Guias e motoristas acessam somente os deslocamentos atribuídos.</a:t>
+              <a:t>Uma plataforma compartilhada, com operação segregada. Cadastros, viagens, reservas e históricos pertencem à empresa. Acesso definido pelo identificador da empresa e pelo perfil do usuário. Um profissional de várias empresas possui um cadastro em cada uma. Nexus administra empresas, planos e configurações da plataforma. Guias e motoristas acessam somente os deslocamentos atribuídos. Políticas públicas e canal para solicitações de privacidade.</a:t>
             </a:r>
           </a:p>
         </p:txBody>
@@ -5875,7 +5875,7 @@
               </a:defRPr>
             </a:pPr>
             <a:r>
-              <a:t>A família inteira, com lugar garantido ao salvar</a:t>
+              <a:t>A família inteira na mesma reserva</a:t>
             </a:r>
           </a:p>
         </p:txBody>
@@ -8401,8 +8401,8 @@
         </p:blipFill>
         <p:spPr>
           <a:xfrm>
-            <a:off x="8514701" y="1005840"/>
-            <a:ext cx="2813076" cy="4754880"/>
+            <a:off x="8728378" y="1005840"/>
+            <a:ext cx="2385723" cy="4754880"/>
           </a:xfrm>
           <a:prstGeom prst="rect">
             <a:avLst/>
@@ -13142,6 +13142,22 @@
             </a:pPr>
             <a:r>
               <a:t>• Nexus administra empresas, planos e configurações da plataforma.</a:t>
+            </a:r>
+          </a:p>
+          <a:p>
+            <a:pPr>
+              <a:spcAft>
+                <a:spcPts val="1100"/>
+              </a:spcAft>
+              <a:defRPr sz="1800" b="0">
+                <a:solidFill>
+                  <a:srgbClr val="0B253F"/>
+                </a:solidFill>
+                <a:latin typeface="Arial"/>
+              </a:defRPr>
+            </a:pPr>
+            <a:r>
+              <a:t>• Políticas públicas e canal para solicitações de privacidade.</a:t>
             </a:r>
           </a:p>
         </p:txBody>

</xml_diff>

<commit_message>
Reforça segurança, privacidade e acessibilidade do Rotafy (#40)
* security: strengthen RLS and dependencies and add privacy rights and accessibility controls

* docs: refresh private editable deck with privacy resources

---------

Co-authored-by: cfartes <23644292+cfartes@users.noreply.github.com>
</commit_message>
<xml_diff>
--- a/backend/private/documentacao/apresentacao.pptx
+++ b/backend/private/documentacao/apresentacao.pptx
@@ -1857,7 +1857,7 @@
           <a:lstStyle/>
           <a:p>
             <a:r>
-              <a:t>Uma plataforma compartilhada, com operação segregada. Cadastros, viagens, reservas e históricos pertencem à empresa. Acesso definido pelo identificador da empresa e pelo perfil do usuário. Um profissional de várias empresas possui um cadastro em cada uma. Nexus administra empresas, planos e configurações da plataforma. Guias e motoristas acessam somente os deslocamentos atribuídos.</a:t>
+              <a:t>Uma plataforma compartilhada, com operação segregada. Cadastros, viagens, reservas e históricos pertencem à empresa. Acesso definido pelo identificador da empresa e pelo perfil do usuário. Um profissional de várias empresas possui um cadastro em cada uma. Nexus administra empresas, planos e configurações da plataforma. Guias e motoristas acessam somente os deslocamentos atribuídos. Políticas públicas e canal para solicitações de privacidade.</a:t>
             </a:r>
           </a:p>
         </p:txBody>
@@ -5875,7 +5875,7 @@
               </a:defRPr>
             </a:pPr>
             <a:r>
-              <a:t>A família inteira, com lugar garantido ao salvar</a:t>
+              <a:t>A família inteira na mesma reserva</a:t>
             </a:r>
           </a:p>
         </p:txBody>
@@ -8401,8 +8401,8 @@
         </p:blipFill>
         <p:spPr>
           <a:xfrm>
-            <a:off x="8514701" y="1005840"/>
-            <a:ext cx="2813076" cy="4754880"/>
+            <a:off x="8728378" y="1005840"/>
+            <a:ext cx="2385723" cy="4754880"/>
           </a:xfrm>
           <a:prstGeom prst="rect">
             <a:avLst/>
@@ -13142,6 +13142,22 @@
             </a:pPr>
             <a:r>
               <a:t>• Nexus administra empresas, planos e configurações da plataforma.</a:t>
+            </a:r>
+          </a:p>
+          <a:p>
+            <a:pPr>
+              <a:spcAft>
+                <a:spcPts val="1100"/>
+              </a:spcAft>
+              <a:defRPr sz="1800" b="0">
+                <a:solidFill>
+                  <a:srgbClr val="0B253F"/>
+                </a:solidFill>
+                <a:latin typeface="Arial"/>
+              </a:defRPr>
+            </a:pPr>
+            <a:r>
+              <a:t>• Políticas públicas e canal para solicitações de privacidade.</a:t>
             </a:r>
           </a:p>
         </p:txBody>

</xml_diff>

<commit_message>
feat: arrival estimates, fleet map and crew departure rules
</commit_message>
<xml_diff>
--- a/backend/private/documentacao/apresentacao.pptx
+++ b/backend/private/documentacao/apresentacao.pptx
@@ -1507,7 +1507,7 @@
           <a:lstStyle/>
           <a:p>
             <a:r>
-              <a:t>Rastreamento e avisos configuráveis pela empresa. Posições do celular responsável coletadas a cada cinco minutos. Mapa com última posição e trilha das amostras durante o trecho. Aviso de proximidade para embarques confirmados no mapa. Lembrete de saída na ida e na volta pelo WhatsApp. Localização aproximada; depende de conexão, GPS e permissões.</a:t>
+              <a:t>Rastreamento e avisos configuráveis pela empresa. Rastreamento automático ao iniciar, com coleta prevista a cada minuto. Mapa geral da frota e histórico individual por veículo. WhatsApp com lembrete de saída e previsão de chegada quando disponível. Localização automática dos embarques e sequência otimizada dos pontos. Requer configuração habilitada e APK atualizado. Estimativas dependem de GPS, rede e trânsito.</a:t>
             </a:r>
           </a:p>
         </p:txBody>
@@ -11095,7 +11095,7 @@
               </a:defRPr>
             </a:pPr>
             <a:r>
-              <a:t>• Posições do celular responsável coletadas a cada cinco minutos.</a:t>
+              <a:t>• Rastreamento automático ao iniciar, com coleta prevista a cada minuto.</a:t>
             </a:r>
           </a:p>
           <a:p>
@@ -11111,7 +11111,7 @@
               </a:defRPr>
             </a:pPr>
             <a:r>
-              <a:t>• Mapa com última posição e trilha das amostras durante o trecho.</a:t>
+              <a:t>• Mapa geral da frota e histórico individual por veículo.</a:t>
             </a:r>
           </a:p>
           <a:p>
@@ -11127,7 +11127,7 @@
               </a:defRPr>
             </a:pPr>
             <a:r>
-              <a:t>• Aviso de proximidade para embarques confirmados no mapa.</a:t>
+              <a:t>• WhatsApp com lembrete de saída e previsão de chegada quando disponível.</a:t>
             </a:r>
           </a:p>
           <a:p>
@@ -11143,7 +11143,7 @@
               </a:defRPr>
             </a:pPr>
             <a:r>
-              <a:t>• Lembrete de saída na ida e na volta pelo WhatsApp.</a:t>
+              <a:t>• Localização automática dos embarques e sequência otimizada dos pontos.</a:t>
             </a:r>
           </a:p>
         </p:txBody>
@@ -11182,7 +11182,7 @@
               </a:defRPr>
             </a:pPr>
             <a:r>
-              <a:t>Localização aproximada; depende de conexão, GPS e permissões.</a:t>
+              <a:t>Requer configuração habilitada e APK atualizado. Estimativas dependem de GPS, rede e trânsito.</a:t>
             </a:r>
           </a:p>
         </p:txBody>

</xml_diff>

<commit_message>
Arrival estimates, fleet map, automatic tracking and crew departure rules (#46)
* feat: arrival estimates, fleet map and crew departure rules

* fix: keep stop optimization independent from arrival notifications

---------

Co-authored-by: cfartes <23644292+cfartes@users.noreply.github.com>
</commit_message>
<xml_diff>
--- a/backend/private/documentacao/apresentacao.pptx
+++ b/backend/private/documentacao/apresentacao.pptx
@@ -1507,7 +1507,7 @@
           <a:lstStyle/>
           <a:p>
             <a:r>
-              <a:t>Rastreamento e avisos configuráveis pela empresa. Posições do celular responsável coletadas a cada cinco minutos. Mapa com última posição e trilha das amostras durante o trecho. Aviso de proximidade para embarques confirmados no mapa. Lembrete de saída na ida e na volta pelo WhatsApp. Localização aproximada; depende de conexão, GPS e permissões.</a:t>
+              <a:t>Rastreamento e avisos configuráveis pela empresa. Rastreamento automático ao iniciar, com coleta prevista a cada minuto. Mapa geral da frota e histórico individual por veículo. WhatsApp com lembrete de saída e previsão de chegada quando disponível. Localização automática dos embarques e sequência otimizada dos pontos. Requer configuração habilitada e APK atualizado. Estimativas dependem de GPS, rede e trânsito.</a:t>
             </a:r>
           </a:p>
         </p:txBody>
@@ -11095,7 +11095,7 @@
               </a:defRPr>
             </a:pPr>
             <a:r>
-              <a:t>• Posições do celular responsável coletadas a cada cinco minutos.</a:t>
+              <a:t>• Rastreamento automático ao iniciar, com coleta prevista a cada minuto.</a:t>
             </a:r>
           </a:p>
           <a:p>
@@ -11111,7 +11111,7 @@
               </a:defRPr>
             </a:pPr>
             <a:r>
-              <a:t>• Mapa com última posição e trilha das amostras durante o trecho.</a:t>
+              <a:t>• Mapa geral da frota e histórico individual por veículo.</a:t>
             </a:r>
           </a:p>
           <a:p>
@@ -11127,7 +11127,7 @@
               </a:defRPr>
             </a:pPr>
             <a:r>
-              <a:t>• Aviso de proximidade para embarques confirmados no mapa.</a:t>
+              <a:t>• WhatsApp com lembrete de saída e previsão de chegada quando disponível.</a:t>
             </a:r>
           </a:p>
           <a:p>
@@ -11143,7 +11143,7 @@
               </a:defRPr>
             </a:pPr>
             <a:r>
-              <a:t>• Lembrete de saída na ida e na volta pelo WhatsApp.</a:t>
+              <a:t>• Localização automática dos embarques e sequência otimizada dos pontos.</a:t>
             </a:r>
           </a:p>
         </p:txBody>
@@ -11182,7 +11182,7 @@
               </a:defRPr>
             </a:pPr>
             <a:r>
-              <a:t>Localização aproximada; depende de conexão, GPS e permissões.</a:t>
+              <a:t>Requer configuração habilitada e APK atualizado. Estimativas dependem de GPS, rede e trânsito.</a:t>
             </a:r>
           </a:p>
         </p:txBody>

</xml_diff>